<commit_message>
docs: refine daily status report visuals
Co-authored-by: 程序员鱼皮 <592789970@qq.com>
</commit_message>
<xml_diff>
--- a/docs/reports/project-status-2026-06-13.pptx
+++ b/docs/reports/project-status-2026-06-13.pptx
@@ -2269,7 +2269,7 @@
                 <a:ea typeface="Calibri" pitchFamily="34" charset="-122"/>
                 <a:cs typeface="Calibri" pitchFamily="34" charset="-120"/>
               </a:rPr>
-              <a:t>HTML / 多文件 / Vue</a:t>
+              <a:t>HTML / Vue 等</a:t>
             </a:r>
             <a:endParaRPr lang="en-US" sz="950" dirty="0"/>
           </a:p>
@@ -2422,7 +2422,7 @@
                 <a:ea typeface="Calibri" pitchFamily="34" charset="-122"/>
                 <a:cs typeface="Calibri" pitchFamily="34" charset="-120"/>
               </a:rPr>
-              <a:t>common / app / ai 等</a:t>
+              <a:t>模块拆分完成</a:t>
             </a:r>
             <a:endParaRPr lang="en-US" sz="950" dirty="0"/>
           </a:p>
@@ -2575,7 +2575,7 @@
                 <a:ea typeface="Calibri" pitchFamily="34" charset="-122"/>
                 <a:cs typeface="Calibri" pitchFamily="34" charset="-120"/>
               </a:rPr>
-              <a:t>后端单体测试目录</a:t>
+              <a:t>单体测试目录</a:t>
             </a:r>
             <a:endParaRPr lang="en-US" sz="950" dirty="0"/>
           </a:p>
@@ -2728,7 +2728,7 @@
                 <a:ea typeface="Calibri" pitchFamily="34" charset="-122"/>
                 <a:cs typeface="Calibri" pitchFamily="34" charset="-120"/>
               </a:rPr>
-              <a:t>本轮报告未见新增</a:t>
+              <a:t>近 7 天无新增</a:t>
             </a:r>
             <a:endParaRPr lang="en-US" sz="950" dirty="0"/>
           </a:p>
@@ -7530,7 +7530,7 @@
 </file>
 
 <file path=ppt/slides/slide5.xml><?xml version="1.0" encoding="utf-8"?>
-<p:sld xmlns:a="http://schemas.openxmlformats.org/drawingml/2006/main" xmlns:r="http://schemas.openxmlformats.org/officeDocument/2006/relationships" xmlns:p="http://schemas.openxmlformats.org/presentationml/2006/main">
+<p:sld xmlns:a="http://schemas.openxmlformats.org/drawingml/2006/main" xmlns:p="http://schemas.openxmlformats.org/presentationml/2006/main">
   <p:cSld name="Slide 5">
     <p:bg>
       <p:bgPr>
@@ -7647,35 +7647,6 @@
             <a:solidFill>
               <a:srgbClr val="D8EEF2">
                 <a:alpha val="70000"/>
-              </a:srgbClr>
-            </a:solidFill>
-            <a:prstDash val="solid"/>
-          </a:ln>
-        </p:spPr>
-      </p:sp>
-      <p:sp>
-        <p:nvSpPr>
-          <p:cNvPr id="6" name="Shape 4"/>
-          <p:cNvSpPr/>
-          <p:nvPr/>
-        </p:nvSpPr>
-        <p:spPr>
-          <a:xfrm>
-            <a:off x="10652760" y="320040"/>
-            <a:ext cx="384048" cy="384048"/>
-          </a:xfrm>
-          <a:prstGeom prst="ellipse">
-            <a:avLst/>
-          </a:prstGeom>
-          <a:solidFill>
-            <a:srgbClr val="02C39A">
-              <a:alpha val="85000"/>
-            </a:srgbClr>
-          </a:solidFill>
-          <a:ln w="12700">
-            <a:solidFill>
-              <a:srgbClr val="02C39A">
-                <a:alpha val="0"/>
               </a:srgbClr>
             </a:solidFill>
             <a:prstDash val="solid"/>
@@ -13306,7 +13277,7 @@
                 <a:ea typeface="Calibri" pitchFamily="34" charset="-122"/>
                 <a:cs typeface="Calibri" pitchFamily="34" charset="-120"/>
               </a:rPr>
-              <a:t>补充 GitHub Actions：后端 Maven test、前端 build/type-check/lint。</a:t>
+              <a:t>新增 CI：Maven test + 前端 build/lint。</a:t>
             </a:r>
             <a:endParaRPr lang="en-US" sz="1250" dirty="0"/>
           </a:p>
@@ -13324,7 +13295,7 @@
                 <a:ea typeface="Calibri" pitchFamily="34" charset="-122"/>
                 <a:cs typeface="Calibri" pitchFamily="34" charset="-120"/>
               </a:rPr>
-              <a:t>为生成模式增加样例回归：HTML、多文件、Vue 工程至少各一组。</a:t>
+              <a:t>为 3 种生成模式补样例回归。</a:t>
             </a:r>
             <a:endParaRPr lang="en-US" sz="1250" dirty="0"/>
           </a:p>
@@ -13598,7 +13569,7 @@
                 <a:ea typeface="Calibri" pitchFamily="34" charset="-122"/>
                 <a:cs typeface="Calibri" pitchFamily="34" charset="-120"/>
               </a:rPr>
-              <a:t>梳理 local/prod/sample 配置边界，减少密钥和环境值散落。</a:t>
+              <a:t>沉淀 local/prod 配置边界。</a:t>
             </a:r>
             <a:endParaRPr lang="en-US" sz="1250" dirty="0"/>
           </a:p>
@@ -13616,7 +13587,7 @@
                 <a:ea typeface="Calibri" pitchFamily="34" charset="-122"/>
                 <a:cs typeface="Calibri" pitchFamily="34" charset="-120"/>
               </a:rPr>
-              <a:t>补齐微服务启动顺序、Nacos/Dubbo 依赖和部署说明。</a:t>
+              <a:t>补齐微服务启动与依赖说明。</a:t>
             </a:r>
             <a:endParaRPr lang="en-US" sz="1250" dirty="0"/>
           </a:p>
@@ -13890,7 +13861,7 @@
                 <a:ea typeface="Calibri" pitchFamily="34" charset="-122"/>
                 <a:cs typeface="Calibri" pitchFamily="34" charset="-120"/>
               </a:rPr>
-              <a:t>验证创建、对话生成、预览、部署、下载、后台管理端到端流程。</a:t>
+              <a:t>走通创建→生成→部署→下载。</a:t>
             </a:r>
             <a:endParaRPr lang="en-US" sz="1250" dirty="0"/>
           </a:p>
@@ -13908,7 +13879,7 @@
                 <a:ea typeface="Calibri" pitchFamily="34" charset="-122"/>
                 <a:cs typeface="Calibri" pitchFamily="34" charset="-120"/>
               </a:rPr>
-              <a:t>持续打磨可视化编辑与增量修改的错误恢复体验。</a:t>
+              <a:t>强化编辑失败恢复体验。</a:t>
             </a:r>
             <a:endParaRPr lang="en-US" sz="1250" dirty="0"/>
           </a:p>
@@ -14182,7 +14153,7 @@
                 <a:ea typeface="Calibri" pitchFamily="34" charset="-122"/>
                 <a:cs typeface="Calibri" pitchFamily="34" charset="-120"/>
               </a:rPr>
-              <a:t>把 AI 调用量、失败率、响应耗时、部署成功率纳入仪表盘。</a:t>
+              <a:t>采集调用量、失败率、耗时。</a:t>
             </a:r>
             <a:endParaRPr lang="en-US" sz="1250" dirty="0"/>
           </a:p>
@@ -14200,7 +14171,7 @@
                 <a:ea typeface="Calibri" pitchFamily="34" charset="-122"/>
                 <a:cs typeface="Calibri" pitchFamily="34" charset="-120"/>
               </a:rPr>
-              <a:t>建立成本指标：模型调用次数、缓存命中率、单次生成成本。</a:t>
+              <a:t>跟踪缓存命中与单次成本。</a:t>
             </a:r>
             <a:endParaRPr lang="en-US" sz="1250" dirty="0"/>
           </a:p>

</xml_diff>